<commit_message>
docs: iBEC v2 package rebuild — structural-triage wording + self-verification tooling
- Report wording tightened: AF2/PRODIGY described as structural triage (not
  validation), candidate counts explicitly include native control, E1 phrased
  without an isolated disorder-conditioning effect
- Dual-protocol candidate-interface results intentionally excluded from claims
  (deployment gate not passed; development-only per contract)
- Add package self-verification (VERIFY_PACKAGE.py, verify_ibec_package.py),
  REPRODUCIBILITY_V2.md, ECLS evidence manifest and CAID3 external analysis
- Rebuilt AnalyzingDisorder.zip (1.704 MB, deadline 2026-09-30)
</commit_message>
<xml_diff>
--- a/iBEC_Submission/build_v2/AnalyzingDisorder/28-AnalyzingDisorder-TechnicalAbstract.pptx
+++ b/iBEC_Submission/build_v2/AnalyzingDisorder/28-AnalyzingDisorder-TechnicalAbstract.pptx
@@ -3698,7 +3698,7 @@
               </a:defRPr>
             </a:pPr>
             <a:r>
-              <a:t>•  Frozen ECLS benchmark and 449-artifact release lineage</a:t>
+              <a:t>•  Frozen ECLS benchmark and 68-file checksummed evidence manifest</a:t>
             </a:r>
           </a:p>
         </p:txBody>
@@ -5228,7 +5228,7 @@
               </a:defRPr>
             </a:pPr>
             <a:r>
-              <a:t>Structure → generation → multi-state scoring → filtering → validation → handoff</a:t>
+              <a:t>Structure → generation → multi-state scoring → filtering → triage → handoff</a:t>
             </a:r>
           </a:p>
         </p:txBody>
@@ -6383,7 +6383,7 @@
               </a:defRPr>
             </a:pPr>
             <a:r>
-              <a:t>•  481 source memberships → 352 unique hypotheses</a:t>
+              <a:t>•  481 source memberships → 352 unique candidates including native</a:t>
             </a:r>
           </a:p>
         </p:txBody>
@@ -6803,7 +6803,7 @@
               </a:defRPr>
             </a:pPr>
             <a:r>
-              <a:t>6. Multi-Seed Structural Validation</a:t>
+              <a:t>6. Multi-Seed Structural Triage</a:t>
             </a:r>
           </a:p>
         </p:txBody>
@@ -7619,7 +7619,7 @@
               </a:defRPr>
             </a:pPr>
             <a:r>
-              <a:t>•  Tau/5MP3: correct 13-aa H3, five poses, 275 unique hypotheses, 163 pass all gates</a:t>
+              <a:t>•  Tau/5MP3: correct 13-aa H3, five poses, 275 candidates including native</a:t>
             </a:r>
           </a:p>
         </p:txBody>

</xml_diff>

<commit_message>
docs: switch primary track to Bioinformatics Resources / Platforms
Rationale: the verified deliverable is the auditable platform (Gradio UI,
CLI, AF2/PRODIGY pipeline, frozen contracts, SHA-256 manifests), not an
AI-driven discovery. Core design hypotheses (contact guidance, multiscaffold
v2, IDP de novo ceiling) reached terminal negative; ECLS discrimination is
positive but bounded. Platform track better matches the evidence.

Changes:
- IBEC_TRACK_DECISION.md: primary=Platforms, secondary=Discovery, scores 92/72/65/58
- IBEC_SCORING_MAP_V2.md: platform-first narrative across all 5 scoring dimensions
- iBEC_PROJECT_REPORT_V2.md: header track fields swapped
- SUBMISSION_CHECKLIST_V2.md: track confirmation item annotated
- SUPPLEMENTARY_README_V2.md: scope section notes new track
- build_ibec_submission_v2.py: fix hardcoded track in slides 1 and 9
- Rebuilt PDFs, PPTX, ZIP, and all SHA-256 manifests (VERIFY_PACKAGE pass)
</commit_message>
<xml_diff>
--- a/iBEC_Submission/build_v2/AnalyzingDisorder/28-AnalyzingDisorder-TechnicalAbstract.pptx
+++ b/iBEC_Submission/build_v2/AnalyzingDisorder/28-AnalyzingDisorder-TechnicalAbstract.pptx
@@ -3323,7 +3323,7 @@
               </a:defRPr>
             </a:pPr>
             <a:r>
-              <a:t>AI-driven Life Science Discovery | iBEC 2026</a:t>
+              <a:t>Bioinformatics Resources / Platforms | iBEC 2026</a:t>
             </a:r>
           </a:p>
         </p:txBody>
@@ -3536,7 +3536,7 @@
               </a:defRPr>
             </a:pPr>
             <a:r>
-              <a:t>Primary track: AI-driven Life Science Discovery</a:t>
+              <a:t>Primary track: Bioinformatics Resources / Platforms</a:t>
             </a:r>
           </a:p>
         </p:txBody>

</xml_diff>